<commit_message>
Finaliza guia de entrega, modelos e pitch
</commit_message>
<xml_diff>
--- a/apresentacao/Meritus_Pitch.pptx
+++ b/apresentacao/Meritus_Pitch.pptx
@@ -2,25 +2,25 @@
 <file path=ppt/presentation.xml><?xml version="1.0" encoding="utf-8"?>
 <p:presentation xmlns:p="http://schemas.openxmlformats.org/presentationml/2006/main">
   <p:sldMasterIdLst>
-    <p:sldMasterId xmlns:r="http://schemas.openxmlformats.org/officeDocument/2006/relationships" id="2147483648" r:id="R5394c126d7664788"/>
+    <p:sldMasterId xmlns:r="http://schemas.openxmlformats.org/officeDocument/2006/relationships" id="2147483648" r:id="Rea879058d7a147a7"/>
   </p:sldMasterIdLst>
   <p:notesMasterIdLst>
-    <p:notesMasterId xmlns:r="http://schemas.openxmlformats.org/officeDocument/2006/relationships" r:id="Rb46f158f75db437a"/>
+    <p:notesMasterId xmlns:r="http://schemas.openxmlformats.org/officeDocument/2006/relationships" r:id="R63d7aacf3a124d25"/>
   </p:notesMasterIdLst>
   <p:sldIdLst>
-    <p:sldId xmlns:r="http://schemas.openxmlformats.org/officeDocument/2006/relationships" id="256" r:id="Ra587ee79e7f841c8"/>
-    <p:sldId xmlns:r="http://schemas.openxmlformats.org/officeDocument/2006/relationships" id="257" r:id="Rd74ebc5c015e4847"/>
-    <p:sldId xmlns:r="http://schemas.openxmlformats.org/officeDocument/2006/relationships" id="258" r:id="R6d6bfa466b984df2"/>
-    <p:sldId xmlns:r="http://schemas.openxmlformats.org/officeDocument/2006/relationships" id="259" r:id="Rae22efe42c964ce1"/>
-    <p:sldId xmlns:r="http://schemas.openxmlformats.org/officeDocument/2006/relationships" id="260" r:id="R1e31788b276646de"/>
-    <p:sldId xmlns:r="http://schemas.openxmlformats.org/officeDocument/2006/relationships" id="261" r:id="R5c694f26b0a441d6"/>
-    <p:sldId xmlns:r="http://schemas.openxmlformats.org/officeDocument/2006/relationships" id="262" r:id="R4cb933e1ddf94caa"/>
-    <p:sldId xmlns:r="http://schemas.openxmlformats.org/officeDocument/2006/relationships" id="263" r:id="R5280df83a96e451d"/>
-    <p:sldId xmlns:r="http://schemas.openxmlformats.org/officeDocument/2006/relationships" id="264" r:id="Rb0aa8b17acf340d7"/>
-    <p:sldId xmlns:r="http://schemas.openxmlformats.org/officeDocument/2006/relationships" id="265" r:id="R352680dfd73c42a7"/>
-    <p:sldId xmlns:r="http://schemas.openxmlformats.org/officeDocument/2006/relationships" id="266" r:id="R92bb40a8f20e409b"/>
-    <p:sldId xmlns:r="http://schemas.openxmlformats.org/officeDocument/2006/relationships" id="267" r:id="R4d34b3eb2eb04fd6"/>
-    <p:sldId xmlns:r="http://schemas.openxmlformats.org/officeDocument/2006/relationships" id="268" r:id="Rf69e514ee9844f65"/>
+    <p:sldId xmlns:r="http://schemas.openxmlformats.org/officeDocument/2006/relationships" id="256" r:id="R0e32dbeebcd04d6b"/>
+    <p:sldId xmlns:r="http://schemas.openxmlformats.org/officeDocument/2006/relationships" id="257" r:id="Rd58f1b39d6214892"/>
+    <p:sldId xmlns:r="http://schemas.openxmlformats.org/officeDocument/2006/relationships" id="258" r:id="R64e9cecf240646d2"/>
+    <p:sldId xmlns:r="http://schemas.openxmlformats.org/officeDocument/2006/relationships" id="259" r:id="Rfe3ca5146b9b4da3"/>
+    <p:sldId xmlns:r="http://schemas.openxmlformats.org/officeDocument/2006/relationships" id="260" r:id="R2fff6a0b39ba440e"/>
+    <p:sldId xmlns:r="http://schemas.openxmlformats.org/officeDocument/2006/relationships" id="261" r:id="R80bf0244b09f4f0e"/>
+    <p:sldId xmlns:r="http://schemas.openxmlformats.org/officeDocument/2006/relationships" id="262" r:id="R004109eaf18e4b80"/>
+    <p:sldId xmlns:r="http://schemas.openxmlformats.org/officeDocument/2006/relationships" id="263" r:id="R87c5603aa60e4366"/>
+    <p:sldId xmlns:r="http://schemas.openxmlformats.org/officeDocument/2006/relationships" id="264" r:id="R1fc4c03fe7334f33"/>
+    <p:sldId xmlns:r="http://schemas.openxmlformats.org/officeDocument/2006/relationships" id="265" r:id="Re8bfee004b8d4bbc"/>
+    <p:sldId xmlns:r="http://schemas.openxmlformats.org/officeDocument/2006/relationships" id="266" r:id="Re0b44db519ad414a"/>
+    <p:sldId xmlns:r="http://schemas.openxmlformats.org/officeDocument/2006/relationships" id="267" r:id="R01b456fb496740db"/>
+    <p:sldId xmlns:r="http://schemas.openxmlformats.org/officeDocument/2006/relationships" id="268" r:id="Rfcca6c0ad6a44307"/>
   </p:sldIdLst>
   <p:sldSz cx="12192000" cy="6858000"/>
   <p:notesSz cx="6858000" cy="9144000"/>
@@ -3737,12 +3737,12 @@
   </p:cSld>
   <p:clrMap bg1="lt1" tx1="dk1" bg2="lt2" tx2="dk2" accent1="accent1" accent2="accent2" accent3="accent3" accent4="accent4" accent5="accent5" accent6="accent6" hlink="hlink" folHlink="folHlink"/>
   <p:sldLayoutIdLst>
-    <p:sldLayoutId xmlns:r="http://schemas.openxmlformats.org/officeDocument/2006/relationships" id="2147483649" r:id="R3071a8bc38694080"/>
-    <p:sldLayoutId xmlns:r="http://schemas.openxmlformats.org/officeDocument/2006/relationships" id="2147483650" r:id="Rb05949d1c7ef4249"/>
-    <p:sldLayoutId xmlns:r="http://schemas.openxmlformats.org/officeDocument/2006/relationships" id="2147483651" r:id="R862d27484b6b4aa9"/>
-    <p:sldLayoutId xmlns:r="http://schemas.openxmlformats.org/officeDocument/2006/relationships" id="2147483652" r:id="R5467ccb1bec14b84"/>
-    <p:sldLayoutId xmlns:r="http://schemas.openxmlformats.org/officeDocument/2006/relationships" id="2147483653" r:id="R7ce6c036498c4731"/>
-    <p:sldLayoutId xmlns:r="http://schemas.openxmlformats.org/officeDocument/2006/relationships" id="2147483654" r:id="Rc5717fc1d01f465b"/>
+    <p:sldLayoutId xmlns:r="http://schemas.openxmlformats.org/officeDocument/2006/relationships" id="2147483649" r:id="Rab6573004d3a44c9"/>
+    <p:sldLayoutId xmlns:r="http://schemas.openxmlformats.org/officeDocument/2006/relationships" id="2147483650" r:id="Rc7ae259c63fb4523"/>
+    <p:sldLayoutId xmlns:r="http://schemas.openxmlformats.org/officeDocument/2006/relationships" id="2147483651" r:id="Re962389ca70e49da"/>
+    <p:sldLayoutId xmlns:r="http://schemas.openxmlformats.org/officeDocument/2006/relationships" id="2147483652" r:id="Rf8537a4720f34618"/>
+    <p:sldLayoutId xmlns:r="http://schemas.openxmlformats.org/officeDocument/2006/relationships" id="2147483653" r:id="R97ec57fd23e9432b"/>
+    <p:sldLayoutId xmlns:r="http://schemas.openxmlformats.org/officeDocument/2006/relationships" id="2147483654" r:id="Re0418705ce9a495b"/>
   </p:sldLayoutIdLst>
   <p:txStyles>
     <p:titleStyle>
@@ -16844,7 +16844,7 @@
                 <a:ea typeface="Arial"/>
                 <a:cs typeface="Arial"/>
               </a:rPr>
-              <a:t>Do reconhecimento à utilização da vantagem</a:t>
+              <a:t>Exemplo com saldo inicial do aluno igual a zero</a:t>
             </a:r>
           </a:p>
         </p:txBody>
@@ -17780,7 +17780,7 @@
                 <a:ea typeface="Arial"/>
                 <a:cs typeface="Arial"/>
               </a:rPr>
-              <a:t>moedas de saldo final*</a:t>
+              <a:t>moedas de saldo final</a:t>
             </a:r>
           </a:p>
         </p:txBody>

</xml_diff>

<commit_message>
Publica na Cloudflare Free e atualiza endereco da entrega
</commit_message>
<xml_diff>
--- a/apresentacao/Meritus_Pitch.pptx
+++ b/apresentacao/Meritus_Pitch.pptx
@@ -2,25 +2,25 @@
 <file path=ppt/presentation.xml><?xml version="1.0" encoding="utf-8"?>
 <p:presentation xmlns:p="http://schemas.openxmlformats.org/presentationml/2006/main">
   <p:sldMasterIdLst>
-    <p:sldMasterId xmlns:r="http://schemas.openxmlformats.org/officeDocument/2006/relationships" id="2147483648" r:id="Rea879058d7a147a7"/>
+    <p:sldMasterId xmlns:r="http://schemas.openxmlformats.org/officeDocument/2006/relationships" id="2147483648" r:id="Ra1516f650c0d4b01"/>
   </p:sldMasterIdLst>
   <p:notesMasterIdLst>
-    <p:notesMasterId xmlns:r="http://schemas.openxmlformats.org/officeDocument/2006/relationships" r:id="R63d7aacf3a124d25"/>
+    <p:notesMasterId xmlns:r="http://schemas.openxmlformats.org/officeDocument/2006/relationships" r:id="Raedfe8663e4344f6"/>
   </p:notesMasterIdLst>
   <p:sldIdLst>
-    <p:sldId xmlns:r="http://schemas.openxmlformats.org/officeDocument/2006/relationships" id="256" r:id="R0e32dbeebcd04d6b"/>
-    <p:sldId xmlns:r="http://schemas.openxmlformats.org/officeDocument/2006/relationships" id="257" r:id="Rd58f1b39d6214892"/>
-    <p:sldId xmlns:r="http://schemas.openxmlformats.org/officeDocument/2006/relationships" id="258" r:id="R64e9cecf240646d2"/>
-    <p:sldId xmlns:r="http://schemas.openxmlformats.org/officeDocument/2006/relationships" id="259" r:id="Rfe3ca5146b9b4da3"/>
-    <p:sldId xmlns:r="http://schemas.openxmlformats.org/officeDocument/2006/relationships" id="260" r:id="R2fff6a0b39ba440e"/>
-    <p:sldId xmlns:r="http://schemas.openxmlformats.org/officeDocument/2006/relationships" id="261" r:id="R80bf0244b09f4f0e"/>
-    <p:sldId xmlns:r="http://schemas.openxmlformats.org/officeDocument/2006/relationships" id="262" r:id="R004109eaf18e4b80"/>
-    <p:sldId xmlns:r="http://schemas.openxmlformats.org/officeDocument/2006/relationships" id="263" r:id="R87c5603aa60e4366"/>
-    <p:sldId xmlns:r="http://schemas.openxmlformats.org/officeDocument/2006/relationships" id="264" r:id="R1fc4c03fe7334f33"/>
-    <p:sldId xmlns:r="http://schemas.openxmlformats.org/officeDocument/2006/relationships" id="265" r:id="Re8bfee004b8d4bbc"/>
-    <p:sldId xmlns:r="http://schemas.openxmlformats.org/officeDocument/2006/relationships" id="266" r:id="Re0b44db519ad414a"/>
-    <p:sldId xmlns:r="http://schemas.openxmlformats.org/officeDocument/2006/relationships" id="267" r:id="R01b456fb496740db"/>
-    <p:sldId xmlns:r="http://schemas.openxmlformats.org/officeDocument/2006/relationships" id="268" r:id="Rfcca6c0ad6a44307"/>
+    <p:sldId xmlns:r="http://schemas.openxmlformats.org/officeDocument/2006/relationships" id="256" r:id="R7b705a4c60784724"/>
+    <p:sldId xmlns:r="http://schemas.openxmlformats.org/officeDocument/2006/relationships" id="257" r:id="R46a4d51ce60649e8"/>
+    <p:sldId xmlns:r="http://schemas.openxmlformats.org/officeDocument/2006/relationships" id="258" r:id="Ra8d6abad3b5d428e"/>
+    <p:sldId xmlns:r="http://schemas.openxmlformats.org/officeDocument/2006/relationships" id="259" r:id="Rffc8e882450a438a"/>
+    <p:sldId xmlns:r="http://schemas.openxmlformats.org/officeDocument/2006/relationships" id="260" r:id="Re86fdb1a621a484f"/>
+    <p:sldId xmlns:r="http://schemas.openxmlformats.org/officeDocument/2006/relationships" id="261" r:id="R848e4782a2824037"/>
+    <p:sldId xmlns:r="http://schemas.openxmlformats.org/officeDocument/2006/relationships" id="262" r:id="Red33c15950bf4b09"/>
+    <p:sldId xmlns:r="http://schemas.openxmlformats.org/officeDocument/2006/relationships" id="263" r:id="Rc424b52719144cb1"/>
+    <p:sldId xmlns:r="http://schemas.openxmlformats.org/officeDocument/2006/relationships" id="264" r:id="R89c9a51519fb406e"/>
+    <p:sldId xmlns:r="http://schemas.openxmlformats.org/officeDocument/2006/relationships" id="265" r:id="R35207350f0b545b8"/>
+    <p:sldId xmlns:r="http://schemas.openxmlformats.org/officeDocument/2006/relationships" id="266" r:id="R84a8871195674be9"/>
+    <p:sldId xmlns:r="http://schemas.openxmlformats.org/officeDocument/2006/relationships" id="267" r:id="R0655ab500bf84e3e"/>
+    <p:sldId xmlns:r="http://schemas.openxmlformats.org/officeDocument/2006/relationships" id="268" r:id="Rceba1412cd024322"/>
   </p:sldIdLst>
   <p:sldSz cx="12192000" cy="6858000"/>
   <p:notesSz cx="6858000" cy="9144000"/>
@@ -737,6 +737,11 @@
               <a:t>18:30–20:00. Encerrar com a proposta e abrir perguntas. Próxima etapa: piloto com uma turma e parceiros, medindo adesão e resgates, sem inventar resultados. Repositório: https://github.com/vianadv/sistemaMoedaEstudantil.</a:t>
             </a:r>
           </a:p>
+          <a:p xmlns:a="http://schemas.openxmlformats.org/drawingml/2006/main">
+            <a:r>
+              <a:t>Site público em Cloudflare Workers Free e D1 Free: https://meritus-estudantil.vianadv.workers.dev. Contas fictícias na tela inicial.</a:t>
+            </a:r>
+          </a:p>
         </p:txBody>
       </p:sp>
       <p:sp>
@@ -3737,12 +3742,12 @@
   </p:cSld>
   <p:clrMap bg1="lt1" tx1="dk1" bg2="lt2" tx2="dk2" accent1="accent1" accent2="accent2" accent3="accent3" accent4="accent4" accent5="accent5" accent6="accent6" hlink="hlink" folHlink="folHlink"/>
   <p:sldLayoutIdLst>
-    <p:sldLayoutId xmlns:r="http://schemas.openxmlformats.org/officeDocument/2006/relationships" id="2147483649" r:id="Rab6573004d3a44c9"/>
-    <p:sldLayoutId xmlns:r="http://schemas.openxmlformats.org/officeDocument/2006/relationships" id="2147483650" r:id="Rc7ae259c63fb4523"/>
-    <p:sldLayoutId xmlns:r="http://schemas.openxmlformats.org/officeDocument/2006/relationships" id="2147483651" r:id="Re962389ca70e49da"/>
-    <p:sldLayoutId xmlns:r="http://schemas.openxmlformats.org/officeDocument/2006/relationships" id="2147483652" r:id="Rf8537a4720f34618"/>
-    <p:sldLayoutId xmlns:r="http://schemas.openxmlformats.org/officeDocument/2006/relationships" id="2147483653" r:id="R97ec57fd23e9432b"/>
-    <p:sldLayoutId xmlns:r="http://schemas.openxmlformats.org/officeDocument/2006/relationships" id="2147483654" r:id="Re0418705ce9a495b"/>
+    <p:sldLayoutId xmlns:r="http://schemas.openxmlformats.org/officeDocument/2006/relationships" id="2147483649" r:id="R8d572c3355aa4971"/>
+    <p:sldLayoutId xmlns:r="http://schemas.openxmlformats.org/officeDocument/2006/relationships" id="2147483650" r:id="Rd7166f3951a34833"/>
+    <p:sldLayoutId xmlns:r="http://schemas.openxmlformats.org/officeDocument/2006/relationships" id="2147483651" r:id="R11ca008bc1f9492b"/>
+    <p:sldLayoutId xmlns:r="http://schemas.openxmlformats.org/officeDocument/2006/relationships" id="2147483652" r:id="Ra220ee06b6724b57"/>
+    <p:sldLayoutId xmlns:r="http://schemas.openxmlformats.org/officeDocument/2006/relationships" id="2147483653" r:id="R27a7a1fc8e9043ee"/>
+    <p:sldLayoutId xmlns:r="http://schemas.openxmlformats.org/officeDocument/2006/relationships" id="2147483654" r:id="Re2bc666631804af4"/>
   </p:sldLayoutIdLst>
   <p:txStyles>
     <p:titleStyle>
@@ -10230,7 +10235,7 @@
                 <a:ea typeface="Arial"/>
                 <a:cs typeface="Arial"/>
               </a:rPr>
-              <a:t>Meritus conecta esforço, mérito e oportunidades.</a:t>
+              <a:t>Acesse: meritus-estudantil.vianadv.workers.dev</a:t>
             </a:r>
           </a:p>
         </p:txBody>

</xml_diff>

<commit_message>
Simplifica infraestrutura e organiza documentacao da entrega
</commit_message>
<xml_diff>
--- a/apresentacao/Meritus_Pitch.pptx
+++ b/apresentacao/Meritus_Pitch.pptx
@@ -2,25 +2,25 @@
 <file path=ppt/presentation.xml><?xml version="1.0" encoding="utf-8"?>
 <p:presentation xmlns:p="http://schemas.openxmlformats.org/presentationml/2006/main">
   <p:sldMasterIdLst>
-    <p:sldMasterId xmlns:r="http://schemas.openxmlformats.org/officeDocument/2006/relationships" id="2147483648" r:id="Ra1516f650c0d4b01"/>
+    <p:sldMasterId xmlns:r="http://schemas.openxmlformats.org/officeDocument/2006/relationships" id="2147483648" r:id="Rdacf29e1611a479f"/>
   </p:sldMasterIdLst>
   <p:notesMasterIdLst>
-    <p:notesMasterId xmlns:r="http://schemas.openxmlformats.org/officeDocument/2006/relationships" r:id="Raedfe8663e4344f6"/>
+    <p:notesMasterId xmlns:r="http://schemas.openxmlformats.org/officeDocument/2006/relationships" r:id="R38e00ee49ff544aa"/>
   </p:notesMasterIdLst>
   <p:sldIdLst>
-    <p:sldId xmlns:r="http://schemas.openxmlformats.org/officeDocument/2006/relationships" id="256" r:id="R7b705a4c60784724"/>
-    <p:sldId xmlns:r="http://schemas.openxmlformats.org/officeDocument/2006/relationships" id="257" r:id="R46a4d51ce60649e8"/>
-    <p:sldId xmlns:r="http://schemas.openxmlformats.org/officeDocument/2006/relationships" id="258" r:id="Ra8d6abad3b5d428e"/>
-    <p:sldId xmlns:r="http://schemas.openxmlformats.org/officeDocument/2006/relationships" id="259" r:id="Rffc8e882450a438a"/>
-    <p:sldId xmlns:r="http://schemas.openxmlformats.org/officeDocument/2006/relationships" id="260" r:id="Re86fdb1a621a484f"/>
-    <p:sldId xmlns:r="http://schemas.openxmlformats.org/officeDocument/2006/relationships" id="261" r:id="R848e4782a2824037"/>
-    <p:sldId xmlns:r="http://schemas.openxmlformats.org/officeDocument/2006/relationships" id="262" r:id="Red33c15950bf4b09"/>
-    <p:sldId xmlns:r="http://schemas.openxmlformats.org/officeDocument/2006/relationships" id="263" r:id="Rc424b52719144cb1"/>
-    <p:sldId xmlns:r="http://schemas.openxmlformats.org/officeDocument/2006/relationships" id="264" r:id="R89c9a51519fb406e"/>
-    <p:sldId xmlns:r="http://schemas.openxmlformats.org/officeDocument/2006/relationships" id="265" r:id="R35207350f0b545b8"/>
-    <p:sldId xmlns:r="http://schemas.openxmlformats.org/officeDocument/2006/relationships" id="266" r:id="R84a8871195674be9"/>
-    <p:sldId xmlns:r="http://schemas.openxmlformats.org/officeDocument/2006/relationships" id="267" r:id="R0655ab500bf84e3e"/>
-    <p:sldId xmlns:r="http://schemas.openxmlformats.org/officeDocument/2006/relationships" id="268" r:id="Rceba1412cd024322"/>
+    <p:sldId xmlns:r="http://schemas.openxmlformats.org/officeDocument/2006/relationships" id="256" r:id="R0288eb70d13a4e42"/>
+    <p:sldId xmlns:r="http://schemas.openxmlformats.org/officeDocument/2006/relationships" id="257" r:id="R7869685dcf674878"/>
+    <p:sldId xmlns:r="http://schemas.openxmlformats.org/officeDocument/2006/relationships" id="258" r:id="R722e1f5a7daf41cf"/>
+    <p:sldId xmlns:r="http://schemas.openxmlformats.org/officeDocument/2006/relationships" id="259" r:id="Rdefaefdcd150485e"/>
+    <p:sldId xmlns:r="http://schemas.openxmlformats.org/officeDocument/2006/relationships" id="260" r:id="R8275ea87104b462c"/>
+    <p:sldId xmlns:r="http://schemas.openxmlformats.org/officeDocument/2006/relationships" id="261" r:id="R20b9486c51154b1b"/>
+    <p:sldId xmlns:r="http://schemas.openxmlformats.org/officeDocument/2006/relationships" id="262" r:id="R2221016139544118"/>
+    <p:sldId xmlns:r="http://schemas.openxmlformats.org/officeDocument/2006/relationships" id="263" r:id="R2d1ea5ff3e744dee"/>
+    <p:sldId xmlns:r="http://schemas.openxmlformats.org/officeDocument/2006/relationships" id="264" r:id="R2ff806daa9684569"/>
+    <p:sldId xmlns:r="http://schemas.openxmlformats.org/officeDocument/2006/relationships" id="265" r:id="Rbf2b78b084ec47d8"/>
+    <p:sldId xmlns:r="http://schemas.openxmlformats.org/officeDocument/2006/relationships" id="266" r:id="R6cbfa4f9fa274eca"/>
+    <p:sldId xmlns:r="http://schemas.openxmlformats.org/officeDocument/2006/relationships" id="267" r:id="Ra2d856af5b524c00"/>
+    <p:sldId xmlns:r="http://schemas.openxmlformats.org/officeDocument/2006/relationships" id="268" r:id="Rb003825e556e42e7"/>
   </p:sldIdLst>
   <p:sldSz cx="12192000" cy="6858000"/>
   <p:notesSz cx="6858000" cy="9144000"/>
@@ -1089,7 +1089,7 @@
           <a:lstStyle xmlns:a="http://schemas.openxmlformats.org/drawingml/2006/main"/>
           <a:p xmlns:a="http://schemas.openxmlformats.org/drawingml/2006/main">
             <a:r>
-              <a:t>8:00–9:45. View em src/views. Controller é a função api de AppController.mjs. Model inclui regras MeritService, EmailService e registros relacionais via Repository DAO. Não criamos classes de entidades sem uso. server.mjs e worker/app.ts adaptam os dois ambientes para o mesmo controlador. Vinext/Vite são infraestrutura de hospedagem.</a:t>
+              <a:t>8:00–9:45. View em src/views. Controller é a função api de AppController.mjs. Model inclui regras MeritService, EmailService e registros relacionais via Repository DAO. Não criamos classes de entidades sem uso. server.mjs e worker/app.mjs adaptam os dois ambientes para o mesmo controlador. O esbuild reúne a interface e o backend em um Worker ESM; a hospedagem usa Cloudflare Workers e D1.</a:t>
             </a:r>
           </a:p>
         </p:txBody>
@@ -3742,12 +3742,12 @@
   </p:cSld>
   <p:clrMap bg1="lt1" tx1="dk1" bg2="lt2" tx2="dk2" accent1="accent1" accent2="accent2" accent3="accent3" accent4="accent4" accent5="accent5" accent6="accent6" hlink="hlink" folHlink="folHlink"/>
   <p:sldLayoutIdLst>
-    <p:sldLayoutId xmlns:r="http://schemas.openxmlformats.org/officeDocument/2006/relationships" id="2147483649" r:id="R8d572c3355aa4971"/>
-    <p:sldLayoutId xmlns:r="http://schemas.openxmlformats.org/officeDocument/2006/relationships" id="2147483650" r:id="Rd7166f3951a34833"/>
-    <p:sldLayoutId xmlns:r="http://schemas.openxmlformats.org/officeDocument/2006/relationships" id="2147483651" r:id="R11ca008bc1f9492b"/>
-    <p:sldLayoutId xmlns:r="http://schemas.openxmlformats.org/officeDocument/2006/relationships" id="2147483652" r:id="Ra220ee06b6724b57"/>
-    <p:sldLayoutId xmlns:r="http://schemas.openxmlformats.org/officeDocument/2006/relationships" id="2147483653" r:id="R27a7a1fc8e9043ee"/>
-    <p:sldLayoutId xmlns:r="http://schemas.openxmlformats.org/officeDocument/2006/relationships" id="2147483654" r:id="Re2bc666631804af4"/>
+    <p:sldLayoutId xmlns:r="http://schemas.openxmlformats.org/officeDocument/2006/relationships" id="2147483649" r:id="R0d417c1493844e95"/>
+    <p:sldLayoutId xmlns:r="http://schemas.openxmlformats.org/officeDocument/2006/relationships" id="2147483650" r:id="Rc8ee5e0d660a4ea0"/>
+    <p:sldLayoutId xmlns:r="http://schemas.openxmlformats.org/officeDocument/2006/relationships" id="2147483651" r:id="R12f3d817f6e6492f"/>
+    <p:sldLayoutId xmlns:r="http://schemas.openxmlformats.org/officeDocument/2006/relationships" id="2147483652" r:id="R1b63a83dbba14dff"/>
+    <p:sldLayoutId xmlns:r="http://schemas.openxmlformats.org/officeDocument/2006/relationships" id="2147483653" r:id="R323b30cb20a24699"/>
+    <p:sldLayoutId xmlns:r="http://schemas.openxmlformats.org/officeDocument/2006/relationships" id="2147483654" r:id="Ra346e2dd78004e5e"/>
   </p:sldLayoutIdLst>
   <p:txStyles>
     <p:titleStyle>

</xml_diff>